<commit_message>
feat: remove o Premya do Smart Dealer — módulo, base do robô e decks
Sai a rota /premya (página + simulador + lib/premya-data.ts) e o item do
menu em "Banco & Fidelização". A base de conhecimento do assistente perde o
bloco "3. PROGRAMA PREMYA" — restam as campanhas por modelo e Campeões de
Vendas.

Nos decks: o slide "A inteligência em ação · Premya" foi removido (diretoria
19 → 18 slides) e as menções ao programa saíram das tabelas de KPI, processo,
concorrentes, papéis e cronograma da banca. A conta do potencial anual perdeu
os ~R$ 148 mil do salto Bronze→Ouro, então o número-manchete cai de
~R$ 1,1 milhão para ~R$ 940 mil (400 campanhas + 490 K2 + 50 seguros/consórcio)
nos quatro lugares onde aparecia. Os dois .pptx foram regerados.

Co-Authored-By: Claude Opus 5 (1M context) <noreply@anthropic.com>
Claude-Session: https://claude.ai/code/session_01G66wSYGXYxCEEBYvXLQhVA
</commit_message>
<xml_diff>
--- a/_NOVAS MELHORIAS/DECK-BANCA-YAMAHAWAY.pptx
+++ b/_NOVAS MELHORIAS/DECK-BANCA-YAMAHAWAY.pptx
@@ -2110,7 +2110,7 @@
                   <c:v>Gap do K2 R$ 490 mil</c:v>
                 </c:pt>
                 <c:pt idx="2">
-                  <c:v>Premya+Seg+Cons R$ 200 mil</c:v>
+                  <c:v>Seguros + Consórcio R$ 50 mil</c:v>
                 </c:pt>
               </c:strCache>
             </c:strRef>
@@ -2127,7 +2127,7 @@
                   <c:v>490</c:v>
                 </c:pt>
                 <c:pt idx="2">
-                  <c:v>200</c:v>
+                  <c:v>50</c:v>
                 </c:pt>
               </c:numCache>
             </c:numRef>
@@ -9823,7 +9823,7 @@
                 <a:ea typeface="Calibri" pitchFamily="34" charset="-122"/>
                 <a:cs typeface="Calibri" pitchFamily="34" charset="-120"/>
               </a:rPr>
-              <a:t>Liberacred, Premya, Seguros, Consórcio, Voz do Cliente</a:t>
+              <a:t>Liberacred, Seguros, Consórcio, Voz do Cliente</a:t>
             </a:r>
             <a:endParaRPr lang="en-US" sz="900" dirty="0"/>
           </a:p>
@@ -11746,280 +11746,6 @@
                   </a:tcPr>
                 </a:tc>
               </a:tr>
-              <a:tr h="493776">
-                <a:tc>
-                  <a:txBody>
-                    <a:bodyPr/>
-                    <a:lstStyle/>
-                    <a:p>
-                      <a:pPr algn="l" indent="0" marL="0">
-                        <a:buNone/>
-                      </a:pPr>
-                      <a:r>
-                        <a:rPr lang="en-US" sz="1050" b="1" dirty="0">
-                          <a:solidFill>
-                            <a:srgbClr val="091426"/>
-                          </a:solidFill>
-                          <a:latin typeface="Calibri" pitchFamily="34" charset="0"/>
-                          <a:ea typeface="Calibri" pitchFamily="34" charset="-122"/>
-                          <a:cs typeface="Calibri" pitchFamily="34" charset="-120"/>
-                        </a:rPr>
-                        <a:t>Índice de Fidelidade Premya</a:t>
-                      </a:r>
-                      <a:endParaRPr lang="en-US" sz="1050" dirty="0">
-                        <a:latin typeface="Calibri" charset="0"/>
-                        <a:ea typeface="Calibri" charset="0"/>
-                        <a:cs typeface="Calibri" charset="0"/>
-                      </a:endParaRPr>
-                    </a:p>
-                  </a:txBody>
-                  <a:tcPr marL="91440" marR="91440" marT="54864" marB="54864" anchor="ctr">
-                    <a:lnL w="9525" cap="flat" cmpd="sng" algn="ctr">
-                      <a:solidFill>
-                        <a:srgbClr val="FFFFFF"/>
-                      </a:solidFill>
-                      <a:prstDash val="solid"/>
-                      <a:round/>
-                      <a:headEnd type="none" w="med" len="med"/>
-                      <a:tailEnd type="none" w="med" len="med"/>
-                    </a:lnL>
-                    <a:lnR w="9525" cap="flat" cmpd="sng" algn="ctr">
-                      <a:solidFill>
-                        <a:srgbClr val="FFFFFF"/>
-                      </a:solidFill>
-                      <a:prstDash val="solid"/>
-                      <a:round/>
-                      <a:headEnd type="none" w="med" len="med"/>
-                      <a:tailEnd type="none" w="med" len="med"/>
-                    </a:lnR>
-                    <a:lnT w="9525" cap="flat" cmpd="sng" algn="ctr">
-                      <a:solidFill>
-                        <a:srgbClr val="FFFFFF"/>
-                      </a:solidFill>
-                      <a:prstDash val="solid"/>
-                      <a:round/>
-                      <a:headEnd type="none" w="med" len="med"/>
-                      <a:tailEnd type="none" w="med" len="med"/>
-                    </a:lnT>
-                    <a:lnB w="9525" cap="flat" cmpd="sng" algn="ctr">
-                      <a:solidFill>
-                        <a:srgbClr val="FFFFFF"/>
-                      </a:solidFill>
-                      <a:prstDash val="solid"/>
-                      <a:round/>
-                      <a:headEnd type="none" w="med" len="med"/>
-                      <a:tailEnd type="none" w="med" len="med"/>
-                    </a:lnB>
-                    <a:solidFill>
-                      <a:srgbClr val="F7F9FC"/>
-                    </a:solidFill>
-                  </a:tcPr>
-                </a:tc>
-                <a:tc>
-                  <a:txBody>
-                    <a:bodyPr/>
-                    <a:lstStyle/>
-                    <a:p>
-                      <a:pPr algn="l" indent="0" marL="0">
-                        <a:buNone/>
-                      </a:pPr>
-                      <a:r>
-                        <a:rPr lang="en-US" sz="1050" dirty="0">
-                          <a:solidFill>
-                            <a:srgbClr val="4A5568"/>
-                          </a:solidFill>
-                          <a:latin typeface="Calibri" pitchFamily="34" charset="0"/>
-                          <a:ea typeface="Calibri" pitchFamily="34" charset="-122"/>
-                          <a:cs typeface="Calibri" pitchFamily="34" charset="-120"/>
-                        </a:rPr>
-                        <a:t>Ouro (85%)</a:t>
-                      </a:r>
-                      <a:endParaRPr lang="en-US" sz="1050" dirty="0">
-                        <a:latin typeface="Calibri" charset="0"/>
-                        <a:ea typeface="Calibri" charset="0"/>
-                        <a:cs typeface="Calibri" charset="0"/>
-                      </a:endParaRPr>
-                    </a:p>
-                  </a:txBody>
-                  <a:tcPr marL="91440" marR="91440" marT="54864" marB="54864" anchor="ctr">
-                    <a:lnL w="9525" cap="flat" cmpd="sng" algn="ctr">
-                      <a:solidFill>
-                        <a:srgbClr val="FFFFFF"/>
-                      </a:solidFill>
-                      <a:prstDash val="solid"/>
-                      <a:round/>
-                      <a:headEnd type="none" w="med" len="med"/>
-                      <a:tailEnd type="none" w="med" len="med"/>
-                    </a:lnL>
-                    <a:lnR w="9525" cap="flat" cmpd="sng" algn="ctr">
-                      <a:solidFill>
-                        <a:srgbClr val="FFFFFF"/>
-                      </a:solidFill>
-                      <a:prstDash val="solid"/>
-                      <a:round/>
-                      <a:headEnd type="none" w="med" len="med"/>
-                      <a:tailEnd type="none" w="med" len="med"/>
-                    </a:lnR>
-                    <a:lnT w="9525" cap="flat" cmpd="sng" algn="ctr">
-                      <a:solidFill>
-                        <a:srgbClr val="FFFFFF"/>
-                      </a:solidFill>
-                      <a:prstDash val="solid"/>
-                      <a:round/>
-                      <a:headEnd type="none" w="med" len="med"/>
-                      <a:tailEnd type="none" w="med" len="med"/>
-                    </a:lnT>
-                    <a:lnB w="9525" cap="flat" cmpd="sng" algn="ctr">
-                      <a:solidFill>
-                        <a:srgbClr val="FFFFFF"/>
-                      </a:solidFill>
-                      <a:prstDash val="solid"/>
-                      <a:round/>
-                      <a:headEnd type="none" w="med" len="med"/>
-                      <a:tailEnd type="none" w="med" len="med"/>
-                    </a:lnB>
-                    <a:solidFill>
-                      <a:srgbClr val="F7F9FC"/>
-                    </a:solidFill>
-                  </a:tcPr>
-                </a:tc>
-                <a:tc>
-                  <a:txBody>
-                    <a:bodyPr/>
-                    <a:lstStyle/>
-                    <a:p>
-                      <a:pPr algn="l" indent="0" marL="0">
-                        <a:buNone/>
-                      </a:pPr>
-                      <a:r>
-                        <a:rPr lang="en-US" sz="1050" dirty="0">
-                          <a:solidFill>
-                            <a:srgbClr val="B7791F"/>
-                          </a:solidFill>
-                          <a:latin typeface="Calibri" pitchFamily="34" charset="0"/>
-                          <a:ea typeface="Calibri" pitchFamily="34" charset="-122"/>
-                          <a:cs typeface="Calibri" pitchFamily="34" charset="-120"/>
-                        </a:rPr>
-                        <a:t>Bronze · 71,6%</a:t>
-                      </a:r>
-                      <a:endParaRPr lang="en-US" sz="1050" dirty="0">
-                        <a:latin typeface="Calibri" charset="0"/>
-                        <a:ea typeface="Calibri" charset="0"/>
-                        <a:cs typeface="Calibri" charset="0"/>
-                      </a:endParaRPr>
-                    </a:p>
-                  </a:txBody>
-                  <a:tcPr marL="91440" marR="91440" marT="54864" marB="54864" anchor="ctr">
-                    <a:lnL w="9525" cap="flat" cmpd="sng" algn="ctr">
-                      <a:solidFill>
-                        <a:srgbClr val="FFFFFF"/>
-                      </a:solidFill>
-                      <a:prstDash val="solid"/>
-                      <a:round/>
-                      <a:headEnd type="none" w="med" len="med"/>
-                      <a:tailEnd type="none" w="med" len="med"/>
-                    </a:lnL>
-                    <a:lnR w="9525" cap="flat" cmpd="sng" algn="ctr">
-                      <a:solidFill>
-                        <a:srgbClr val="FFFFFF"/>
-                      </a:solidFill>
-                      <a:prstDash val="solid"/>
-                      <a:round/>
-                      <a:headEnd type="none" w="med" len="med"/>
-                      <a:tailEnd type="none" w="med" len="med"/>
-                    </a:lnR>
-                    <a:lnT w="9525" cap="flat" cmpd="sng" algn="ctr">
-                      <a:solidFill>
-                        <a:srgbClr val="FFFFFF"/>
-                      </a:solidFill>
-                      <a:prstDash val="solid"/>
-                      <a:round/>
-                      <a:headEnd type="none" w="med" len="med"/>
-                      <a:tailEnd type="none" w="med" len="med"/>
-                    </a:lnT>
-                    <a:lnB w="9525" cap="flat" cmpd="sng" algn="ctr">
-                      <a:solidFill>
-                        <a:srgbClr val="FFFFFF"/>
-                      </a:solidFill>
-                      <a:prstDash val="solid"/>
-                      <a:round/>
-                      <a:headEnd type="none" w="med" len="med"/>
-                      <a:tailEnd type="none" w="med" len="med"/>
-                    </a:lnB>
-                    <a:solidFill>
-                      <a:srgbClr val="F7F9FC"/>
-                    </a:solidFill>
-                  </a:tcPr>
-                </a:tc>
-                <a:tc>
-                  <a:txBody>
-                    <a:bodyPr/>
-                    <a:lstStyle/>
-                    <a:p>
-                      <a:pPr algn="l" indent="0" marL="0">
-                        <a:buNone/>
-                      </a:pPr>
-                      <a:r>
-                        <a:rPr lang="en-US" sz="1050" dirty="0">
-                          <a:solidFill>
-                            <a:srgbClr val="0365FE"/>
-                          </a:solidFill>
-                          <a:latin typeface="Calibri" pitchFamily="34" charset="0"/>
-                          <a:ea typeface="Calibri" pitchFamily="34" charset="-122"/>
-                          <a:cs typeface="Calibri" pitchFamily="34" charset="-120"/>
-                        </a:rPr>
-                        <a:t>Premya + simulador</a:t>
-                      </a:r>
-                      <a:endParaRPr lang="en-US" sz="1050" dirty="0">
-                        <a:latin typeface="Calibri" charset="0"/>
-                        <a:ea typeface="Calibri" charset="0"/>
-                        <a:cs typeface="Calibri" charset="0"/>
-                      </a:endParaRPr>
-                    </a:p>
-                  </a:txBody>
-                  <a:tcPr marL="91440" marR="91440" marT="54864" marB="54864" anchor="ctr">
-                    <a:lnL w="9525" cap="flat" cmpd="sng" algn="ctr">
-                      <a:solidFill>
-                        <a:srgbClr val="FFFFFF"/>
-                      </a:solidFill>
-                      <a:prstDash val="solid"/>
-                      <a:round/>
-                      <a:headEnd type="none" w="med" len="med"/>
-                      <a:tailEnd type="none" w="med" len="med"/>
-                    </a:lnL>
-                    <a:lnR w="9525" cap="flat" cmpd="sng" algn="ctr">
-                      <a:solidFill>
-                        <a:srgbClr val="FFFFFF"/>
-                      </a:solidFill>
-                      <a:prstDash val="solid"/>
-                      <a:round/>
-                      <a:headEnd type="none" w="med" len="med"/>
-                      <a:tailEnd type="none" w="med" len="med"/>
-                    </a:lnR>
-                    <a:lnT w="9525" cap="flat" cmpd="sng" algn="ctr">
-                      <a:solidFill>
-                        <a:srgbClr val="FFFFFF"/>
-                      </a:solidFill>
-                      <a:prstDash val="solid"/>
-                      <a:round/>
-                      <a:headEnd type="none" w="med" len="med"/>
-                      <a:tailEnd type="none" w="med" len="med"/>
-                    </a:lnT>
-                    <a:lnB w="9525" cap="flat" cmpd="sng" algn="ctr">
-                      <a:solidFill>
-                        <a:srgbClr val="FFFFFF"/>
-                      </a:solidFill>
-                      <a:prstDash val="solid"/>
-                      <a:round/>
-                      <a:headEnd type="none" w="med" len="med"/>
-                      <a:tailEnd type="none" w="med" len="med"/>
-                    </a:lnB>
-                    <a:solidFill>
-                      <a:srgbClr val="F7F9FC"/>
-                    </a:solidFill>
-                  </a:tcPr>
-                </a:tc>
-              </a:tr>
             </a:tbl>
           </a:graphicData>
         </a:graphic>
@@ -13728,7 +13454,7 @@
                 <a:ea typeface="Calibri" pitchFamily="34" charset="-122"/>
                 <a:cs typeface="Calibri" pitchFamily="34" charset="-120"/>
               </a:rPr>
-              <a:t>Potencial anual identificado pelo sistema: cerca de R$ 1,1 milhão</a:t>
+              <a:t>Potencial anual identificado pelo sistema: cerca de R$ 940 mil</a:t>
             </a:r>
             <a:endParaRPr lang="en-US" sz="1350" dirty="0"/>
           </a:p>
@@ -13772,7 +13498,7 @@
                 <a:ea typeface="Calibri" pitchFamily="34" charset="-122"/>
                 <a:cs typeface="Calibri" pitchFamily="34" charset="-120"/>
               </a:rPr>
-              <a:t>Prêmios de campanha (~R$ 400 mil) + gap de absorção do K2 (~R$ 490 mil) + Premya, Seguros e Consórcio (~R$ 200 mil) — em uma única concessionária.</a:t>
+              <a:t>Prêmios de campanha (~R$ 400 mil) + gap de absorção do K2 (~R$ 490 mil) + Seguros e Consórcio (~R$ 50 mil) — em uma única concessionária.</a:t>
             </a:r>
             <a:endParaRPr lang="en-US" sz="1150" dirty="0"/>
           </a:p>
@@ -19283,7 +19009,7 @@
                           <a:ea typeface="Calibri" pitchFamily="34" charset="-122"/>
                           <a:cs typeface="Calibri" pitchFamily="34" charset="-120"/>
                         </a:rPr>
-                        <a:t>tudo: carta, crédito, K2, Premya, ranking</a:t>
+                        <a:t>tudo: carta, crédito, K2, ranking</a:t>
                       </a:r>
                       <a:endParaRPr lang="en-US" sz="1050" dirty="0">
                         <a:latin typeface="Calibri" charset="0"/>
@@ -28154,212 +27880,6 @@
                           <a:ea typeface="Calibri" pitchFamily="34" charset="-122"/>
                           <a:cs typeface="Calibri" pitchFamily="34" charset="-120"/>
                         </a:rPr>
-                        <a:t>Índice Premya</a:t>
-                      </a:r>
-                      <a:endParaRPr lang="en-US" sz="1050" dirty="0">
-                        <a:latin typeface="Calibri" charset="0"/>
-                        <a:ea typeface="Calibri" charset="0"/>
-                        <a:cs typeface="Calibri" charset="0"/>
-                      </a:endParaRPr>
-                    </a:p>
-                  </a:txBody>
-                  <a:tcPr marL="91440" marR="91440" marT="54864" marB="54864" anchor="ctr">
-                    <a:lnL w="9525" cap="flat" cmpd="sng" algn="ctr">
-                      <a:solidFill>
-                        <a:srgbClr val="FFFFFF"/>
-                      </a:solidFill>
-                      <a:prstDash val="solid"/>
-                      <a:round/>
-                      <a:headEnd type="none" w="med" len="med"/>
-                      <a:tailEnd type="none" w="med" len="med"/>
-                    </a:lnL>
-                    <a:lnR w="9525" cap="flat" cmpd="sng" algn="ctr">
-                      <a:solidFill>
-                        <a:srgbClr val="FFFFFF"/>
-                      </a:solidFill>
-                      <a:prstDash val="solid"/>
-                      <a:round/>
-                      <a:headEnd type="none" w="med" len="med"/>
-                      <a:tailEnd type="none" w="med" len="med"/>
-                    </a:lnR>
-                    <a:lnT w="9525" cap="flat" cmpd="sng" algn="ctr">
-                      <a:solidFill>
-                        <a:srgbClr val="FFFFFF"/>
-                      </a:solidFill>
-                      <a:prstDash val="solid"/>
-                      <a:round/>
-                      <a:headEnd type="none" w="med" len="med"/>
-                      <a:tailEnd type="none" w="med" len="med"/>
-                    </a:lnT>
-                    <a:lnB w="9525" cap="flat" cmpd="sng" algn="ctr">
-                      <a:solidFill>
-                        <a:srgbClr val="FFFFFF"/>
-                      </a:solidFill>
-                      <a:prstDash val="solid"/>
-                      <a:round/>
-                      <a:headEnd type="none" w="med" len="med"/>
-                      <a:tailEnd type="none" w="med" len="med"/>
-                    </a:lnB>
-                    <a:solidFill>
-                      <a:srgbClr val="FFFFFF"/>
-                    </a:solidFill>
-                  </a:tcPr>
-                </a:tc>
-                <a:tc>
-                  <a:txBody>
-                    <a:bodyPr/>
-                    <a:lstStyle/>
-                    <a:p>
-                      <a:pPr algn="l" indent="0" marL="0">
-                        <a:buNone/>
-                      </a:pPr>
-                      <a:r>
-                        <a:rPr lang="en-US" sz="1050" dirty="0">
-                          <a:solidFill>
-                            <a:srgbClr val="D64545"/>
-                          </a:solidFill>
-                          <a:latin typeface="Calibri" pitchFamily="34" charset="0"/>
-                          <a:ea typeface="Calibri" pitchFamily="34" charset="-122"/>
-                          <a:cs typeface="Calibri" pitchFamily="34" charset="-120"/>
-                        </a:rPr>
-                        <a:t>descoberto na apuração</a:t>
-                      </a:r>
-                      <a:endParaRPr lang="en-US" sz="1050" dirty="0">
-                        <a:latin typeface="Calibri" charset="0"/>
-                        <a:ea typeface="Calibri" charset="0"/>
-                        <a:cs typeface="Calibri" charset="0"/>
-                      </a:endParaRPr>
-                    </a:p>
-                  </a:txBody>
-                  <a:tcPr marL="91440" marR="91440" marT="54864" marB="54864" anchor="ctr">
-                    <a:lnL w="9525" cap="flat" cmpd="sng" algn="ctr">
-                      <a:solidFill>
-                        <a:srgbClr val="FFFFFF"/>
-                      </a:solidFill>
-                      <a:prstDash val="solid"/>
-                      <a:round/>
-                      <a:headEnd type="none" w="med" len="med"/>
-                      <a:tailEnd type="none" w="med" len="med"/>
-                    </a:lnL>
-                    <a:lnR w="9525" cap="flat" cmpd="sng" algn="ctr">
-                      <a:solidFill>
-                        <a:srgbClr val="FFFFFF"/>
-                      </a:solidFill>
-                      <a:prstDash val="solid"/>
-                      <a:round/>
-                      <a:headEnd type="none" w="med" len="med"/>
-                      <a:tailEnd type="none" w="med" len="med"/>
-                    </a:lnR>
-                    <a:lnT w="9525" cap="flat" cmpd="sng" algn="ctr">
-                      <a:solidFill>
-                        <a:srgbClr val="FFFFFF"/>
-                      </a:solidFill>
-                      <a:prstDash val="solid"/>
-                      <a:round/>
-                      <a:headEnd type="none" w="med" len="med"/>
-                      <a:tailEnd type="none" w="med" len="med"/>
-                    </a:lnT>
-                    <a:lnB w="9525" cap="flat" cmpd="sng" algn="ctr">
-                      <a:solidFill>
-                        <a:srgbClr val="FFFFFF"/>
-                      </a:solidFill>
-                      <a:prstDash val="solid"/>
-                      <a:round/>
-                      <a:headEnd type="none" w="med" len="med"/>
-                      <a:tailEnd type="none" w="med" len="med"/>
-                    </a:lnB>
-                    <a:solidFill>
-                      <a:srgbClr val="FFFFFF"/>
-                    </a:solidFill>
-                  </a:tcPr>
-                </a:tc>
-                <a:tc>
-                  <a:txBody>
-                    <a:bodyPr/>
-                    <a:lstStyle/>
-                    <a:p>
-                      <a:pPr algn="l" indent="0" marL="0">
-                        <a:buNone/>
-                      </a:pPr>
-                      <a:r>
-                        <a:rPr lang="en-US" sz="1050" b="1" dirty="0">
-                          <a:solidFill>
-                            <a:srgbClr val="1E9E5A"/>
-                          </a:solidFill>
-                          <a:latin typeface="Calibri" pitchFamily="34" charset="0"/>
-                          <a:ea typeface="Calibri" pitchFamily="34" charset="-122"/>
-                          <a:cs typeface="Calibri" pitchFamily="34" charset="-120"/>
-                        </a:rPr>
-                        <a:t>acompanhado em curso, com simulador</a:t>
-                      </a:r>
-                      <a:endParaRPr lang="en-US" sz="1050" dirty="0">
-                        <a:latin typeface="Calibri" charset="0"/>
-                        <a:ea typeface="Calibri" charset="0"/>
-                        <a:cs typeface="Calibri" charset="0"/>
-                      </a:endParaRPr>
-                    </a:p>
-                  </a:txBody>
-                  <a:tcPr marL="91440" marR="91440" marT="54864" marB="54864" anchor="ctr">
-                    <a:lnL w="9525" cap="flat" cmpd="sng" algn="ctr">
-                      <a:solidFill>
-                        <a:srgbClr val="FFFFFF"/>
-                      </a:solidFill>
-                      <a:prstDash val="solid"/>
-                      <a:round/>
-                      <a:headEnd type="none" w="med" len="med"/>
-                      <a:tailEnd type="none" w="med" len="med"/>
-                    </a:lnL>
-                    <a:lnR w="9525" cap="flat" cmpd="sng" algn="ctr">
-                      <a:solidFill>
-                        <a:srgbClr val="FFFFFF"/>
-                      </a:solidFill>
-                      <a:prstDash val="solid"/>
-                      <a:round/>
-                      <a:headEnd type="none" w="med" len="med"/>
-                      <a:tailEnd type="none" w="med" len="med"/>
-                    </a:lnR>
-                    <a:lnT w="9525" cap="flat" cmpd="sng" algn="ctr">
-                      <a:solidFill>
-                        <a:srgbClr val="FFFFFF"/>
-                      </a:solidFill>
-                      <a:prstDash val="solid"/>
-                      <a:round/>
-                      <a:headEnd type="none" w="med" len="med"/>
-                      <a:tailEnd type="none" w="med" len="med"/>
-                    </a:lnT>
-                    <a:lnB w="9525" cap="flat" cmpd="sng" algn="ctr">
-                      <a:solidFill>
-                        <a:srgbClr val="FFFFFF"/>
-                      </a:solidFill>
-                      <a:prstDash val="solid"/>
-                      <a:round/>
-                      <a:headEnd type="none" w="med" len="med"/>
-                      <a:tailEnd type="none" w="med" len="med"/>
-                    </a:lnB>
-                    <a:solidFill>
-                      <a:srgbClr val="FFFFFF"/>
-                    </a:solidFill>
-                  </a:tcPr>
-                </a:tc>
-              </a:tr>
-              <a:tr h="457200">
-                <a:tc>
-                  <a:txBody>
-                    <a:bodyPr/>
-                    <a:lstStyle/>
-                    <a:p>
-                      <a:pPr algn="l" indent="0" marL="0">
-                        <a:buNone/>
-                      </a:pPr>
-                      <a:r>
-                        <a:rPr lang="en-US" sz="1050" b="1" dirty="0">
-                          <a:solidFill>
-                            <a:srgbClr val="091426"/>
-                          </a:solidFill>
-                          <a:latin typeface="Calibri" pitchFamily="34" charset="0"/>
-                          <a:ea typeface="Calibri" pitchFamily="34" charset="-122"/>
-                          <a:cs typeface="Calibri" pitchFamily="34" charset="-120"/>
-                        </a:rPr>
                         <a:t>Revisão vencida</a:t>
                       </a:r>
                       <a:endParaRPr lang="en-US" sz="1050" dirty="0">
@@ -28407,7 +27927,7 @@
                       <a:tailEnd type="none" w="med" len="med"/>
                     </a:lnB>
                     <a:solidFill>
-                      <a:srgbClr val="F7F9FC"/>
+                      <a:srgbClr val="FFFFFF"/>
                     </a:solidFill>
                   </a:tcPr>
                 </a:tc>
@@ -28475,7 +27995,7 @@
                       <a:tailEnd type="none" w="med" len="med"/>
                     </a:lnB>
                     <a:solidFill>
-                      <a:srgbClr val="F7F9FC"/>
+                      <a:srgbClr val="FFFFFF"/>
                     </a:solidFill>
                   </a:tcPr>
                 </a:tc>
@@ -28543,7 +28063,7 @@
                       <a:tailEnd type="none" w="med" len="med"/>
                     </a:lnB>
                     <a:solidFill>
-                      <a:srgbClr val="F7F9FC"/>
+                      <a:srgbClr val="FFFFFF"/>
                     </a:solidFill>
                   </a:tcPr>
                 </a:tc>
@@ -28613,7 +28133,7 @@
                       <a:tailEnd type="none" w="med" len="med"/>
                     </a:lnB>
                     <a:solidFill>
-                      <a:srgbClr val="FFFFFF"/>
+                      <a:srgbClr val="F7F9FC"/>
                     </a:solidFill>
                   </a:tcPr>
                 </a:tc>
@@ -28681,7 +28201,7 @@
                       <a:tailEnd type="none" w="med" len="med"/>
                     </a:lnB>
                     <a:solidFill>
-                      <a:srgbClr val="FFFFFF"/>
+                      <a:srgbClr val="F7F9FC"/>
                     </a:solidFill>
                   </a:tcPr>
                 </a:tc>
@@ -28749,7 +28269,7 @@
                       <a:tailEnd type="none" w="med" len="med"/>
                     </a:lnB>
                     <a:solidFill>
-                      <a:srgbClr val="FFFFFF"/>
+                      <a:srgbClr val="F7F9FC"/>
                     </a:solidFill>
                   </a:tcPr>
                 </a:tc>
@@ -29399,7 +28919,7 @@
                 <a:ea typeface="Calibri" pitchFamily="34" charset="-122"/>
                 <a:cs typeface="Calibri" pitchFamily="34" charset="-120"/>
               </a:rPr>
-              <a:t>PREMYA</a:t>
+              <a:t>LIBERACRED</a:t>
             </a:r>
             <a:endParaRPr lang="en-US" sz="900" dirty="0"/>
           </a:p>
@@ -29462,7 +28982,7 @@
                 <a:ea typeface="Calibri" pitchFamily="34" charset="-122"/>
                 <a:cs typeface="Calibri" pitchFamily="34" charset="-120"/>
               </a:rPr>
-              <a:t>LIBERACRED</a:t>
+              <a:t>PDCA OFICIAL</a:t>
             </a:r>
             <a:endParaRPr lang="en-US" sz="900" dirty="0"/>
           </a:p>
@@ -29525,7 +29045,7 @@
                 <a:ea typeface="Calibri" pitchFamily="34" charset="-122"/>
                 <a:cs typeface="Calibri" pitchFamily="34" charset="-120"/>
               </a:rPr>
-              <a:t>PDCA OFICIAL</a:t>
+              <a:t>RÉGUA R1–R4</a:t>
             </a:r>
             <a:endParaRPr lang="en-US" sz="900" dirty="0"/>
           </a:p>
@@ -29534,69 +29054,6 @@
       <p:sp>
         <p:nvSpPr>
           <p:cNvPr id="24" name="Shape 22"/>
-          <p:cNvSpPr/>
-          <p:nvPr/>
-        </p:nvSpPr>
-        <p:spPr>
-          <a:xfrm>
-            <a:off x="9460382" y="2834640"/>
-            <a:ext cx="1951330" cy="566928"/>
-          </a:xfrm>
-          <a:prstGeom prst="roundRect">
-            <a:avLst>
-              <a:gd name="adj" fmla="val 50000"/>
-            </a:avLst>
-          </a:prstGeom>
-          <a:solidFill>
-            <a:srgbClr val="EEF4FF"/>
-          </a:solidFill>
-          <a:ln/>
-        </p:spPr>
-      </p:sp>
-      <p:sp>
-        <p:nvSpPr>
-          <p:cNvPr id="25" name="Text 23"/>
-          <p:cNvSpPr/>
-          <p:nvPr/>
-        </p:nvSpPr>
-        <p:spPr>
-          <a:xfrm>
-            <a:off x="9506102" y="2834640"/>
-            <a:ext cx="1859890" cy="566928"/>
-          </a:xfrm>
-          <a:prstGeom prst="rect">
-            <a:avLst/>
-          </a:prstGeom>
-          <a:noFill/>
-          <a:ln/>
-        </p:spPr>
-        <p:txBody>
-          <a:bodyPr wrap="square" rtlCol="0" anchor="ctr">
-            <a:normAutofit/>
-          </a:bodyPr>
-          <a:lstStyle/>
-          <a:p>
-            <a:pPr algn="ctr" indent="0" marL="0">
-              <a:buNone/>
-            </a:pPr>
-            <a:r>
-              <a:rPr lang="en-US" sz="900" b="1" dirty="0">
-                <a:solidFill>
-                  <a:srgbClr val="0365FE"/>
-                </a:solidFill>
-                <a:latin typeface="Calibri" pitchFamily="34" charset="0"/>
-                <a:ea typeface="Calibri" pitchFamily="34" charset="-122"/>
-                <a:cs typeface="Calibri" pitchFamily="34" charset="-120"/>
-              </a:rPr>
-              <a:t>RÉGUA R1–R4</a:t>
-            </a:r>
-            <a:endParaRPr lang="en-US" sz="900" dirty="0"/>
-          </a:p>
-        </p:txBody>
-      </p:sp>
-      <p:sp>
-        <p:nvSpPr>
-          <p:cNvPr id="26" name="Shape 24"/>
           <p:cNvSpPr/>
           <p:nvPr/>
         </p:nvSpPr>
@@ -29618,7 +29075,7 @@
       </p:sp>
       <p:sp>
         <p:nvSpPr>
-          <p:cNvPr id="27" name="Text 25"/>
+          <p:cNvPr id="25" name="Text 23"/>
           <p:cNvSpPr/>
           <p:nvPr/>
         </p:nvSpPr>
@@ -29659,7 +29116,7 @@
       </p:sp>
       <p:sp>
         <p:nvSpPr>
-          <p:cNvPr id="28" name="Text 26"/>
+          <p:cNvPr id="26" name="Text 24"/>
           <p:cNvSpPr/>
           <p:nvPr/>
         </p:nvSpPr>
@@ -29695,7 +29152,7 @@
                 <a:ea typeface="Calibri" pitchFamily="34" charset="-122"/>
                 <a:cs typeface="Calibri" pitchFamily="34" charset="-120"/>
               </a:rPr>
-              <a:t>As regras que fazem uma concessionária Yamaha performar — carta, campanha, fidelidade ao banco, absorção — só existem codificadas aqui. Replicá-las exige viver a operação, não contratar um dev. Essa foi a resposta que a 1ª banca pediu.</a:t>
+              <a:t>As regras que fazem uma concessionária Yamaha performar — carta, campanha, crédito, absorção — só existem codificadas aqui. Replicá-las exige viver a operação, não contratar um dev. Essa foi a resposta que a 1ª banca pediu.</a:t>
             </a:r>
             <a:endParaRPr lang="en-US" sz="1150" dirty="0"/>
           </a:p>
@@ -29703,7 +29160,7 @@
       </p:sp>
       <p:sp>
         <p:nvSpPr>
-          <p:cNvPr id="29" name="Text 27"/>
+          <p:cNvPr id="27" name="Text 25"/>
           <p:cNvSpPr/>
           <p:nvPr/>
         </p:nvSpPr>
@@ -31440,7 +30897,7 @@
                 <a:ea typeface="Calibri" pitchFamily="34" charset="-122"/>
                 <a:cs typeface="Calibri" pitchFamily="34" charset="-120"/>
               </a:rPr>
-              <a:t>~R$ 1,1 milhão/ano</a:t>
+              <a:t>~R$ 940 mil/ano</a:t>
             </a:r>
             <a:endParaRPr lang="en-US" sz="4000" dirty="0"/>
           </a:p>
@@ -31912,7 +31369,7 @@
                 <a:ea typeface="Calibri" pitchFamily="34" charset="-122"/>
                 <a:cs typeface="Calibri" pitchFamily="34" charset="-120"/>
               </a:rPr>
-              <a:t>Premya + Seguros + Consórcio</a:t>
+              <a:t>Seguros + Consórcio</a:t>
             </a:r>
             <a:endParaRPr lang="en-US" sz="1100" dirty="0"/>
           </a:p>
@@ -31953,7 +31410,7 @@
                 <a:ea typeface="Calibri" pitchFamily="34" charset="-122"/>
                 <a:cs typeface="Calibri" pitchFamily="34" charset="-120"/>
               </a:rPr>
-              <a:t>categoria Ouro + penetração de seguros + Bônus Quality</a:t>
+              <a:t>penetração de seguros (33,6% → 45%) + Bônus Quality do consórcio</a:t>
             </a:r>
             <a:endParaRPr lang="en-US" sz="900" dirty="0"/>
           </a:p>
@@ -31992,7 +31449,7 @@
                 <a:ea typeface="Calibri" pitchFamily="34" charset="-122"/>
                 <a:cs typeface="Calibri" pitchFamily="34" charset="-120"/>
               </a:rPr>
-              <a:t>R$ 200 mil</a:t>
+              <a:t>R$ 50 mil</a:t>
             </a:r>
             <a:endParaRPr lang="en-US" sz="1500" dirty="0"/>
           </a:p>
@@ -37372,7 +36829,7 @@
                 <a:ea typeface="Calibri" pitchFamily="34" charset="-122"/>
                 <a:cs typeface="Calibri" pitchFamily="34" charset="-120"/>
               </a:rPr>
-              <a:t>Nenhuma ferramenta une as pontas — e nenhuma fala "Yamaha": carta, Kaizen, K2, Premya, circulares. A concessionária opera cega entre sistemas que não conversam. Essa lacuna é exatamente a oportunidade do Smart Dealer.</a:t>
+              <a:t>Nenhuma ferramenta une as pontas — e nenhuma fala "Yamaha": carta, Kaizen, K2, circulares. A concessionária opera cega entre sistemas que não conversam. Essa lacuna é exatamente a oportunidade do Smart Dealer.</a:t>
             </a:r>
             <a:endParaRPr lang="en-US" sz="1150" dirty="0"/>
           </a:p>
@@ -38831,7 +38288,7 @@
                           <a:ea typeface="Calibri" pitchFamily="34" charset="-122"/>
                           <a:cs typeface="Calibri" pitchFamily="34" charset="-120"/>
                         </a:rPr>
-                        <a:t>Liberacred / Premya / circulares</a:t>
+                        <a:t>Liberacred / circulares</a:t>
                       </a:r>
                       <a:endParaRPr lang="en-US" sz="900" dirty="0">
                         <a:latin typeface="Calibri" charset="0"/>
@@ -39466,7 +38923,7 @@
                 <a:ea typeface="Calibri" pitchFamily="34" charset="-122"/>
                 <a:cs typeface="Calibri" pitchFamily="34" charset="-120"/>
               </a:rPr>
-              <a:t>A vantagem competitiva é o método Yamaha codificado — o software é só o veículo. Nenhum concorrente carrega carta, Kaizen, K2, Premya e circulares dentro do produto.</a:t>
+              <a:t>A vantagem competitiva é o método Yamaha codificado — o software é só o veículo. Nenhum concorrente carrega carta, Kaizen, K2 e circulares dentro do produto.</a:t>
             </a:r>
             <a:endParaRPr lang="en-US" sz="1150" dirty="0"/>
           </a:p>
@@ -40692,7 +40149,7 @@
                 <a:ea typeface="Calibri" pitchFamily="34" charset="-122"/>
                 <a:cs typeface="Calibri" pitchFamily="34" charset="-120"/>
               </a:rPr>
-              <a:t>Todos os dados existiam; a oportunidade passava despercebida. O valor deixado na mesa foi quantificado: ~R$ 1,1 milhão/ano em uma única concessionária.</a:t>
+              <a:t>Todos os dados existiam; a oportunidade passava despercebida. O valor deixado na mesa foi quantificado: ~R$ 940 mil/ano em uma única concessionária.</a:t>
             </a:r>
             <a:endParaRPr lang="en-US" sz="1150" dirty="0"/>
           </a:p>

</xml_diff>